<commit_message>
Refresh project reports with Colab GPU results
</commit_message>
<xml_diff>
--- a/docs/traffic_sign_recognition_ieee_presentation.pptx
+++ b/docs/traffic_sign_recognition_ieee_presentation.pptx
@@ -2,23 +2,23 @@
 <file path=ppt/presentation.xml><?xml version="1.0" encoding="utf-8"?>
 <p:presentation xmlns:p="http://schemas.openxmlformats.org/presentationml/2006/main">
   <p:sldMasterIdLst>
-    <p:sldMasterId xmlns:r="http://schemas.openxmlformats.org/officeDocument/2006/relationships" id="2147483648" r:id="R5b5c1b30c65846cf"/>
+    <p:sldMasterId xmlns:r="http://schemas.openxmlformats.org/officeDocument/2006/relationships" id="2147483648" r:id="Ra6a1932ca0c34dbc"/>
   </p:sldMasterIdLst>
   <p:notesMasterIdLst>
-    <p:notesMasterId xmlns:r="http://schemas.openxmlformats.org/officeDocument/2006/relationships" r:id="Re04b8f85d1554502"/>
+    <p:notesMasterId xmlns:r="http://schemas.openxmlformats.org/officeDocument/2006/relationships" r:id="Rfeefd2e926444b5d"/>
   </p:notesMasterIdLst>
   <p:sldIdLst>
-    <p:sldId xmlns:r="http://schemas.openxmlformats.org/officeDocument/2006/relationships" id="256" r:id="R33f3f68badb646e2"/>
-    <p:sldId xmlns:r="http://schemas.openxmlformats.org/officeDocument/2006/relationships" id="257" r:id="R472426a39d254819"/>
-    <p:sldId xmlns:r="http://schemas.openxmlformats.org/officeDocument/2006/relationships" id="258" r:id="R5141caa9b2064747"/>
-    <p:sldId xmlns:r="http://schemas.openxmlformats.org/officeDocument/2006/relationships" id="259" r:id="Rd0c48ac68c2343c4"/>
-    <p:sldId xmlns:r="http://schemas.openxmlformats.org/officeDocument/2006/relationships" id="260" r:id="R9fd46805808a402d"/>
-    <p:sldId xmlns:r="http://schemas.openxmlformats.org/officeDocument/2006/relationships" id="261" r:id="R658296da755e45e5"/>
-    <p:sldId xmlns:r="http://schemas.openxmlformats.org/officeDocument/2006/relationships" id="262" r:id="R446cd9d1788744b2"/>
-    <p:sldId xmlns:r="http://schemas.openxmlformats.org/officeDocument/2006/relationships" id="263" r:id="R99d3327ca09745ea"/>
-    <p:sldId xmlns:r="http://schemas.openxmlformats.org/officeDocument/2006/relationships" id="264" r:id="R941caf352caa4ba6"/>
-    <p:sldId xmlns:r="http://schemas.openxmlformats.org/officeDocument/2006/relationships" id="265" r:id="R1659a9fd8509417d"/>
-    <p:sldId xmlns:r="http://schemas.openxmlformats.org/officeDocument/2006/relationships" id="266" r:id="R16a40790ff61402e"/>
+    <p:sldId xmlns:r="http://schemas.openxmlformats.org/officeDocument/2006/relationships" id="256" r:id="R91a160ad2e384f7e"/>
+    <p:sldId xmlns:r="http://schemas.openxmlformats.org/officeDocument/2006/relationships" id="257" r:id="R69904f53066246af"/>
+    <p:sldId xmlns:r="http://schemas.openxmlformats.org/officeDocument/2006/relationships" id="258" r:id="R19b1fb0818e448b1"/>
+    <p:sldId xmlns:r="http://schemas.openxmlformats.org/officeDocument/2006/relationships" id="259" r:id="R913302f6d8974d25"/>
+    <p:sldId xmlns:r="http://schemas.openxmlformats.org/officeDocument/2006/relationships" id="260" r:id="R2ea35d7a9422442e"/>
+    <p:sldId xmlns:r="http://schemas.openxmlformats.org/officeDocument/2006/relationships" id="261" r:id="R28e2778a63fe49be"/>
+    <p:sldId xmlns:r="http://schemas.openxmlformats.org/officeDocument/2006/relationships" id="262" r:id="R30c2b9de7e374ef1"/>
+    <p:sldId xmlns:r="http://schemas.openxmlformats.org/officeDocument/2006/relationships" id="263" r:id="R672dc686a5044319"/>
+    <p:sldId xmlns:r="http://schemas.openxmlformats.org/officeDocument/2006/relationships" id="264" r:id="Rea872e300acd4764"/>
+    <p:sldId xmlns:r="http://schemas.openxmlformats.org/officeDocument/2006/relationships" id="265" r:id="Rf00e0894e82a4d2c"/>
+    <p:sldId xmlns:r="http://schemas.openxmlformats.org/officeDocument/2006/relationships" id="266" r:id="R2cd56d0c7d6d4df2"/>
   </p:sldIdLst>
   <p:sldSz cx="12192000" cy="6858000"/>
   <p:notesSz cx="6858000" cy="9144000"/>
@@ -1220,7 +1220,7 @@
   </p:cSld>
   <p:clrMap bg1="lt1" tx1="dk1" bg2="lt2" tx2="dk2" accent1="accent1" accent2="accent2" accent3="accent3" accent4="accent4" accent5="accent5" accent6="accent6" hlink="hlink" folHlink="folHlink"/>
   <p:sldLayoutIdLst>
-    <p:sldLayoutId xmlns:r="http://schemas.openxmlformats.org/officeDocument/2006/relationships" id="2147483649" r:id="R02c3575f688f46f2"/>
+    <p:sldLayoutId xmlns:r="http://schemas.openxmlformats.org/officeDocument/2006/relationships" id="2147483649" r:id="R4d28adb90bf34fcf"/>
   </p:sldLayoutIdLst>
   <p:txStyles>
     <p:titleStyle>
@@ -1771,7 +1771,7 @@
           <p:cNvPr id="5" name="">
             <a:extLst xmlns:a="http://schemas.openxmlformats.org/drawingml/2006/main">
               <a:ext uri="{FF2B5EF4-FFF2-40B4-BE49-F238E27FC236}">
-                <a16:creationId xmlns:a16="http://schemas.microsoft.com/office/drawing/2014/main" id="{9FD4B3E0-9B01-429B-A870-B1B11E07364B}"/>
+                <a16:creationId xmlns:a16="http://schemas.microsoft.com/office/drawing/2014/main" id="{2508A2AF-A122-482C-B3CB-D556A14E7A5F}"/>
               </a:ext>
             </a:extLst>
           </p:cNvPr>
@@ -1826,7 +1826,7 @@
           <p:cNvPr id="2" name="">
             <a:extLst xmlns:a="http://schemas.openxmlformats.org/drawingml/2006/main">
               <a:ext uri="{FF2B5EF4-FFF2-40B4-BE49-F238E27FC236}">
-                <a16:creationId xmlns:a16="http://schemas.microsoft.com/office/drawing/2014/main" id="{808E81B8-705B-4B14-AB18-D0EB08ACCAFD}"/>
+                <a16:creationId xmlns:a16="http://schemas.microsoft.com/office/drawing/2014/main" id="{A1C46063-2B23-485F-B2E1-1ADAEEE59297}"/>
               </a:ext>
             </a:extLst>
           </p:cNvPr>
@@ -1881,7 +1881,7 @@
           <p:cNvPr id="3" name="">
             <a:extLst xmlns:a="http://schemas.openxmlformats.org/drawingml/2006/main">
               <a:ext uri="{FF2B5EF4-FFF2-40B4-BE49-F238E27FC236}">
-                <a16:creationId xmlns:a16="http://schemas.microsoft.com/office/drawing/2014/main" id="{5E642E0B-F20C-4B33-A0F2-6A3FCD704344}"/>
+                <a16:creationId xmlns:a16="http://schemas.microsoft.com/office/drawing/2014/main" id="{7253D5EC-1745-4EE3-A96D-A1410866AC50}"/>
               </a:ext>
             </a:extLst>
           </p:cNvPr>
@@ -1936,7 +1936,7 @@
           <p:cNvPr id="4" name="">
             <a:extLst xmlns:a="http://schemas.openxmlformats.org/drawingml/2006/main">
               <a:ext uri="{FF2B5EF4-FFF2-40B4-BE49-F238E27FC236}">
-                <a16:creationId xmlns:a16="http://schemas.microsoft.com/office/drawing/2014/main" id="{8B30B002-6F92-483D-826E-AC2194EFB9F7}"/>
+                <a16:creationId xmlns:a16="http://schemas.microsoft.com/office/drawing/2014/main" id="{3849CB91-2CB3-4152-8422-D631471D9387}"/>
               </a:ext>
             </a:extLst>
           </p:cNvPr>
@@ -1989,7 +1989,7 @@
     </p:spTree>
     <p:extLst>
       <p:ext uri="{BB962C8B-B14F-4D97-AF65-F5344CB8AC3E}">
-        <p14:creationId xmlns:p14="http://schemas.microsoft.com/office/powerpoint/2010/main" val="804269698"/>
+        <p14:creationId xmlns:p14="http://schemas.microsoft.com/office/powerpoint/2010/main" val="870451069"/>
       </p:ext>
     </p:extLst>
   </p:cSld>
@@ -2020,7 +2020,7 @@
           <p:cNvPr id="8" name="">
             <a:extLst xmlns:a="http://schemas.openxmlformats.org/drawingml/2006/main">
               <a:ext uri="{FF2B5EF4-FFF2-40B4-BE49-F238E27FC236}">
-                <a16:creationId xmlns:a16="http://schemas.microsoft.com/office/drawing/2014/main" id="{5C48261A-8C45-403C-A475-A894BB8D38B2}"/>
+                <a16:creationId xmlns:a16="http://schemas.microsoft.com/office/drawing/2014/main" id="{DBF231F7-C011-4114-9BAD-FAC5EEF0680C}"/>
               </a:ext>
             </a:extLst>
           </p:cNvPr>
@@ -2075,7 +2075,7 @@
           <p:cNvPr id="2" name="">
             <a:extLst xmlns:a="http://schemas.openxmlformats.org/drawingml/2006/main">
               <a:ext uri="{FF2B5EF4-FFF2-40B4-BE49-F238E27FC236}">
-                <a16:creationId xmlns:a16="http://schemas.microsoft.com/office/drawing/2014/main" id="{E8689AED-C627-4F68-B1C0-2376DFAD30BA}"/>
+                <a16:creationId xmlns:a16="http://schemas.microsoft.com/office/drawing/2014/main" id="{F53299D4-CE8C-4DFD-B2F7-4CC1EA94528C}"/>
               </a:ext>
             </a:extLst>
           </p:cNvPr>
@@ -2130,7 +2130,7 @@
           <p:cNvPr id="3" name="">
             <a:extLst xmlns:a="http://schemas.openxmlformats.org/drawingml/2006/main">
               <a:ext uri="{FF2B5EF4-FFF2-40B4-BE49-F238E27FC236}">
-                <a16:creationId xmlns:a16="http://schemas.microsoft.com/office/drawing/2014/main" id="{9FF6185C-04F0-4CAC-A9D6-A6288444A47B}"/>
+                <a16:creationId xmlns:a16="http://schemas.microsoft.com/office/drawing/2014/main" id="{E3BDEE9F-B9C7-4253-9011-9ECB9BAB4C91}"/>
               </a:ext>
             </a:extLst>
           </p:cNvPr>
@@ -2164,13 +2164,13 @@
           <p:nvPr/>
         </p:nvPicPr>
         <p:blipFill>
-          <a:blip xmlns:r="http://schemas.openxmlformats.org/officeDocument/2006/relationships" xmlns:a="http://schemas.openxmlformats.org/drawingml/2006/main" r:embed="R2618feb2ff7e490b"/>
+          <a:blip xmlns:r="http://schemas.openxmlformats.org/officeDocument/2006/relationships" xmlns:a="http://schemas.openxmlformats.org/drawingml/2006/main" r:embed="R7c0a7ce113cd4a87"/>
           <a:stretch xmlns:a="http://schemas.openxmlformats.org/drawingml/2006/main"/>
         </p:blipFill>
         <p:spPr>
           <a:xfrm xmlns:a="http://schemas.openxmlformats.org/drawingml/2006/main">
-            <a:off x="1143000" y="1809750"/>
-            <a:ext cx="2857500" cy="2857500"/>
+            <a:off x="857250" y="1941260"/>
+            <a:ext cx="3429000" cy="2594480"/>
           </a:xfrm>
           <a:prstGeom xmlns:a="http://schemas.openxmlformats.org/drawingml/2006/main" prst="rect">
             <a:avLst/>
@@ -2182,7 +2182,7 @@
           <p:cNvPr id="5" name="">
             <a:extLst xmlns:a="http://schemas.openxmlformats.org/drawingml/2006/main">
               <a:ext uri="{FF2B5EF4-FFF2-40B4-BE49-F238E27FC236}">
-                <a16:creationId xmlns:a16="http://schemas.microsoft.com/office/drawing/2014/main" id="{A9ED9AC0-44AB-4327-ABBF-752D389250B9}"/>
+                <a16:creationId xmlns:a16="http://schemas.microsoft.com/office/drawing/2014/main" id="{9A8CA78B-D6EC-4F81-AC5C-C6C122CAF7F7}"/>
               </a:ext>
             </a:extLst>
           </p:cNvPr>
@@ -2237,7 +2237,7 @@
           <p:cNvPr id="6" name="">
             <a:extLst xmlns:a="http://schemas.openxmlformats.org/drawingml/2006/main">
               <a:ext uri="{FF2B5EF4-FFF2-40B4-BE49-F238E27FC236}">
-                <a16:creationId xmlns:a16="http://schemas.microsoft.com/office/drawing/2014/main" id="{C4BA9F7F-6629-480D-92CE-176482B565FE}"/>
+                <a16:creationId xmlns:a16="http://schemas.microsoft.com/office/drawing/2014/main" id="{7F163285-C24C-4760-8D4A-6EE104F82E49}"/>
               </a:ext>
             </a:extLst>
           </p:cNvPr>
@@ -2292,7 +2292,7 @@
           <p:cNvPr id="7" name="">
             <a:extLst xmlns:a="http://schemas.openxmlformats.org/drawingml/2006/main">
               <a:ext uri="{FF2B5EF4-FFF2-40B4-BE49-F238E27FC236}">
-                <a16:creationId xmlns:a16="http://schemas.microsoft.com/office/drawing/2014/main" id="{889B8A99-C8AE-4A5C-B9AC-7E1970BC94F1}"/>
+                <a16:creationId xmlns:a16="http://schemas.microsoft.com/office/drawing/2014/main" id="{BD2581A5-5A27-4CEA-A5FE-E58ED964841F}"/>
               </a:ext>
             </a:extLst>
           </p:cNvPr>
@@ -2345,7 +2345,7 @@
     </p:spTree>
     <p:extLst>
       <p:ext uri="{BB962C8B-B14F-4D97-AF65-F5344CB8AC3E}">
-        <p14:creationId xmlns:p14="http://schemas.microsoft.com/office/powerpoint/2010/main" val="1249539682"/>
+        <p14:creationId xmlns:p14="http://schemas.microsoft.com/office/powerpoint/2010/main" val="1541980390"/>
       </p:ext>
     </p:extLst>
   </p:cSld>
@@ -2376,7 +2376,7 @@
           <p:cNvPr id="9" name="">
             <a:extLst xmlns:a="http://schemas.openxmlformats.org/drawingml/2006/main">
               <a:ext uri="{FF2B5EF4-FFF2-40B4-BE49-F238E27FC236}">
-                <a16:creationId xmlns:a16="http://schemas.microsoft.com/office/drawing/2014/main" id="{31FF143D-8815-44D6-92F9-9740255D24AD}"/>
+                <a16:creationId xmlns:a16="http://schemas.microsoft.com/office/drawing/2014/main" id="{9BE5B574-5B2A-4FD8-8378-FFE56D692130}"/>
               </a:ext>
             </a:extLst>
           </p:cNvPr>
@@ -2431,7 +2431,7 @@
           <p:cNvPr id="2" name="">
             <a:extLst xmlns:a="http://schemas.openxmlformats.org/drawingml/2006/main">
               <a:ext uri="{FF2B5EF4-FFF2-40B4-BE49-F238E27FC236}">
-                <a16:creationId xmlns:a16="http://schemas.microsoft.com/office/drawing/2014/main" id="{B7A3A9A9-F958-4981-9530-973824FD033C}"/>
+                <a16:creationId xmlns:a16="http://schemas.microsoft.com/office/drawing/2014/main" id="{C1F35B52-5CFB-4958-BAC7-01FF0C5CA8D2}"/>
               </a:ext>
             </a:extLst>
           </p:cNvPr>
@@ -2486,7 +2486,7 @@
           <p:cNvPr id="3" name="">
             <a:extLst xmlns:a="http://schemas.openxmlformats.org/drawingml/2006/main">
               <a:ext uri="{FF2B5EF4-FFF2-40B4-BE49-F238E27FC236}">
-                <a16:creationId xmlns:a16="http://schemas.microsoft.com/office/drawing/2014/main" id="{3972EE29-9C35-4A02-A41F-3714C20A1DA4}"/>
+                <a16:creationId xmlns:a16="http://schemas.microsoft.com/office/drawing/2014/main" id="{9E6342A6-9FB6-48F2-A8E7-0B7DCB25B147}"/>
               </a:ext>
             </a:extLst>
           </p:cNvPr>
@@ -2516,7 +2516,7 @@
           <p:cNvPr id="4" name="">
             <a:extLst xmlns:a="http://schemas.openxmlformats.org/drawingml/2006/main">
               <a:ext uri="{FF2B5EF4-FFF2-40B4-BE49-F238E27FC236}">
-                <a16:creationId xmlns:a16="http://schemas.microsoft.com/office/drawing/2014/main" id="{42F2A895-EA20-43E0-8861-C84A92F3C377}"/>
+                <a16:creationId xmlns:a16="http://schemas.microsoft.com/office/drawing/2014/main" id="{DC76718B-8CF5-4D8C-9DED-45043B91A082}"/>
               </a:ext>
             </a:extLst>
           </p:cNvPr>
@@ -2571,7 +2571,7 @@
           <p:cNvPr id="5" name="">
             <a:extLst xmlns:a="http://schemas.openxmlformats.org/drawingml/2006/main">
               <a:ext uri="{FF2B5EF4-FFF2-40B4-BE49-F238E27FC236}">
-                <a16:creationId xmlns:a16="http://schemas.microsoft.com/office/drawing/2014/main" id="{216F04D5-5703-4598-8EE2-6CB203976C67}"/>
+                <a16:creationId xmlns:a16="http://schemas.microsoft.com/office/drawing/2014/main" id="{64E1B18F-32D3-4BE9-815B-A089D8041666}"/>
               </a:ext>
             </a:extLst>
           </p:cNvPr>
@@ -2672,7 +2672,7 @@
           <p:cNvPr id="6" name="">
             <a:extLst xmlns:a="http://schemas.openxmlformats.org/drawingml/2006/main">
               <a:ext uri="{FF2B5EF4-FFF2-40B4-BE49-F238E27FC236}">
-                <a16:creationId xmlns:a16="http://schemas.microsoft.com/office/drawing/2014/main" id="{06A4F4B6-4BA4-422F-B47F-661CB6067D01}"/>
+                <a16:creationId xmlns:a16="http://schemas.microsoft.com/office/drawing/2014/main" id="{52C3318E-9ABA-4783-8A07-F9306BA4170A}"/>
               </a:ext>
             </a:extLst>
           </p:cNvPr>
@@ -2727,7 +2727,7 @@
           <p:cNvPr id="7" name="">
             <a:extLst xmlns:a="http://schemas.openxmlformats.org/drawingml/2006/main">
               <a:ext uri="{FF2B5EF4-FFF2-40B4-BE49-F238E27FC236}">
-                <a16:creationId xmlns:a16="http://schemas.microsoft.com/office/drawing/2014/main" id="{0B669636-E173-4CD5-838D-AD83F05DCAD0}"/>
+                <a16:creationId xmlns:a16="http://schemas.microsoft.com/office/drawing/2014/main" id="{10F7225A-BC19-4A29-B203-BFEE15D80255}"/>
               </a:ext>
             </a:extLst>
           </p:cNvPr>
@@ -2828,7 +2828,7 @@
           <p:cNvPr id="8" name="">
             <a:extLst xmlns:a="http://schemas.openxmlformats.org/drawingml/2006/main">
               <a:ext uri="{FF2B5EF4-FFF2-40B4-BE49-F238E27FC236}">
-                <a16:creationId xmlns:a16="http://schemas.microsoft.com/office/drawing/2014/main" id="{323CCD3E-EBA0-4BE1-894B-980FF5FE72CC}"/>
+                <a16:creationId xmlns:a16="http://schemas.microsoft.com/office/drawing/2014/main" id="{30FF2A44-1B9E-4D26-B2F8-383A347ECB51}"/>
               </a:ext>
             </a:extLst>
           </p:cNvPr>
@@ -2881,7 +2881,7 @@
     </p:spTree>
     <p:extLst>
       <p:ext uri="{BB962C8B-B14F-4D97-AF65-F5344CB8AC3E}">
-        <p14:creationId xmlns:p14="http://schemas.microsoft.com/office/powerpoint/2010/main" val="849713789"/>
+        <p14:creationId xmlns:p14="http://schemas.microsoft.com/office/powerpoint/2010/main" val="25878815"/>
       </p:ext>
     </p:extLst>
   </p:cSld>
@@ -2912,7 +2912,7 @@
           <p:cNvPr id="11" name="">
             <a:extLst xmlns:a="http://schemas.openxmlformats.org/drawingml/2006/main">
               <a:ext uri="{FF2B5EF4-FFF2-40B4-BE49-F238E27FC236}">
-                <a16:creationId xmlns:a16="http://schemas.microsoft.com/office/drawing/2014/main" id="{FF6AC442-FE4A-478F-884F-331255F6CDF3}"/>
+                <a16:creationId xmlns:a16="http://schemas.microsoft.com/office/drawing/2014/main" id="{B2876A3A-D57B-4F02-8570-0914994D590E}"/>
               </a:ext>
             </a:extLst>
           </p:cNvPr>
@@ -2967,7 +2967,7 @@
           <p:cNvPr id="2" name="">
             <a:extLst xmlns:a="http://schemas.openxmlformats.org/drawingml/2006/main">
               <a:ext uri="{FF2B5EF4-FFF2-40B4-BE49-F238E27FC236}">
-                <a16:creationId xmlns:a16="http://schemas.microsoft.com/office/drawing/2014/main" id="{F9DE5E0B-E82F-498A-B509-72D88032CBC3}"/>
+                <a16:creationId xmlns:a16="http://schemas.microsoft.com/office/drawing/2014/main" id="{ACD53D2E-D238-466B-B1D6-84F6CF5C3608}"/>
               </a:ext>
             </a:extLst>
           </p:cNvPr>
@@ -3022,7 +3022,7 @@
           <p:cNvPr id="3" name="">
             <a:extLst xmlns:a="http://schemas.openxmlformats.org/drawingml/2006/main">
               <a:ext uri="{FF2B5EF4-FFF2-40B4-BE49-F238E27FC236}">
-                <a16:creationId xmlns:a16="http://schemas.microsoft.com/office/drawing/2014/main" id="{96DE874C-B191-4DC4-A8CF-270C6B9393B8}"/>
+                <a16:creationId xmlns:a16="http://schemas.microsoft.com/office/drawing/2014/main" id="{7E9D8017-0E0D-4A89-BFDB-20621E577218}"/>
               </a:ext>
             </a:extLst>
           </p:cNvPr>
@@ -3052,7 +3052,7 @@
           <p:cNvPr id="4" name="">
             <a:extLst xmlns:a="http://schemas.openxmlformats.org/drawingml/2006/main">
               <a:ext uri="{FF2B5EF4-FFF2-40B4-BE49-F238E27FC236}">
-                <a16:creationId xmlns:a16="http://schemas.microsoft.com/office/drawing/2014/main" id="{4BA04997-96E9-4229-A295-7500F2E586B3}"/>
+                <a16:creationId xmlns:a16="http://schemas.microsoft.com/office/drawing/2014/main" id="{F7C3962D-B551-4B6D-B48A-37BE2C50420A}"/>
               </a:ext>
             </a:extLst>
           </p:cNvPr>
@@ -3107,7 +3107,7 @@
           <p:cNvPr id="5" name="">
             <a:extLst xmlns:a="http://schemas.openxmlformats.org/drawingml/2006/main">
               <a:ext uri="{FF2B5EF4-FFF2-40B4-BE49-F238E27FC236}">
-                <a16:creationId xmlns:a16="http://schemas.microsoft.com/office/drawing/2014/main" id="{5E2A442B-C674-477A-857B-1488D3D23410}"/>
+                <a16:creationId xmlns:a16="http://schemas.microsoft.com/office/drawing/2014/main" id="{3BA5F64C-5083-4444-B334-EA2F691FF204}"/>
               </a:ext>
             </a:extLst>
           </p:cNvPr>
@@ -3162,7 +3162,7 @@
           <p:cNvPr id="6" name="">
             <a:extLst xmlns:a="http://schemas.openxmlformats.org/drawingml/2006/main">
               <a:ext uri="{FF2B5EF4-FFF2-40B4-BE49-F238E27FC236}">
-                <a16:creationId xmlns:a16="http://schemas.microsoft.com/office/drawing/2014/main" id="{5EB20B09-45B9-4EF0-A622-D0E23FDF860B}"/>
+                <a16:creationId xmlns:a16="http://schemas.microsoft.com/office/drawing/2014/main" id="{7561083A-EE68-4BF0-B792-D6AAA3FE0257}"/>
               </a:ext>
             </a:extLst>
           </p:cNvPr>
@@ -3217,7 +3217,7 @@
           <p:cNvPr id="7" name="">
             <a:extLst xmlns:a="http://schemas.openxmlformats.org/drawingml/2006/main">
               <a:ext uri="{FF2B5EF4-FFF2-40B4-BE49-F238E27FC236}">
-                <a16:creationId xmlns:a16="http://schemas.microsoft.com/office/drawing/2014/main" id="{80CC85CF-33E5-4C19-9281-8A3A83725440}"/>
+                <a16:creationId xmlns:a16="http://schemas.microsoft.com/office/drawing/2014/main" id="{6FC94038-B892-4DC1-AF4A-4FDF34583E01}"/>
               </a:ext>
             </a:extLst>
           </p:cNvPr>
@@ -3272,7 +3272,7 @@
           <p:cNvPr id="8" name="">
             <a:extLst xmlns:a="http://schemas.openxmlformats.org/drawingml/2006/main">
               <a:ext uri="{FF2B5EF4-FFF2-40B4-BE49-F238E27FC236}">
-                <a16:creationId xmlns:a16="http://schemas.microsoft.com/office/drawing/2014/main" id="{D69883B9-4F17-4650-B5E6-D9115D895F43}"/>
+                <a16:creationId xmlns:a16="http://schemas.microsoft.com/office/drawing/2014/main" id="{70E64146-33F5-406B-B5E3-92A20CBDC711}"/>
               </a:ext>
             </a:extLst>
           </p:cNvPr>
@@ -3327,7 +3327,7 @@
           <p:cNvPr id="9" name="">
             <a:extLst xmlns:a="http://schemas.openxmlformats.org/drawingml/2006/main">
               <a:ext uri="{FF2B5EF4-FFF2-40B4-BE49-F238E27FC236}">
-                <a16:creationId xmlns:a16="http://schemas.microsoft.com/office/drawing/2014/main" id="{F935A0DF-9B7B-47A2-B0E8-93FEE928C0A3}"/>
+                <a16:creationId xmlns:a16="http://schemas.microsoft.com/office/drawing/2014/main" id="{B4685CC0-BD7E-4908-9EF4-65958CE04A12}"/>
               </a:ext>
             </a:extLst>
           </p:cNvPr>
@@ -3382,7 +3382,7 @@
           <p:cNvPr id="10" name="">
             <a:extLst xmlns:a="http://schemas.openxmlformats.org/drawingml/2006/main">
               <a:ext uri="{FF2B5EF4-FFF2-40B4-BE49-F238E27FC236}">
-                <a16:creationId xmlns:a16="http://schemas.microsoft.com/office/drawing/2014/main" id="{F191AA11-4448-492A-ACBC-E7FC2DE00A60}"/>
+                <a16:creationId xmlns:a16="http://schemas.microsoft.com/office/drawing/2014/main" id="{7CEA61EC-55D5-4886-AAEF-7B2156295032}"/>
               </a:ext>
             </a:extLst>
           </p:cNvPr>
@@ -3435,7 +3435,7 @@
     </p:spTree>
     <p:extLst>
       <p:ext uri="{BB962C8B-B14F-4D97-AF65-F5344CB8AC3E}">
-        <p14:creationId xmlns:p14="http://schemas.microsoft.com/office/powerpoint/2010/main" val="1416772545"/>
+        <p14:creationId xmlns:p14="http://schemas.microsoft.com/office/powerpoint/2010/main" val="713892271"/>
       </p:ext>
     </p:extLst>
   </p:cSld>
@@ -3466,7 +3466,7 @@
           <p:cNvPr id="11" name="">
             <a:extLst xmlns:a="http://schemas.openxmlformats.org/drawingml/2006/main">
               <a:ext uri="{FF2B5EF4-FFF2-40B4-BE49-F238E27FC236}">
-                <a16:creationId xmlns:a16="http://schemas.microsoft.com/office/drawing/2014/main" id="{7B36242B-5E6D-461C-83E6-368177609433}"/>
+                <a16:creationId xmlns:a16="http://schemas.microsoft.com/office/drawing/2014/main" id="{30C68576-34E8-46B1-B5C6-3F0B1DD589F1}"/>
               </a:ext>
             </a:extLst>
           </p:cNvPr>
@@ -3521,7 +3521,7 @@
           <p:cNvPr id="2" name="">
             <a:extLst xmlns:a="http://schemas.openxmlformats.org/drawingml/2006/main">
               <a:ext uri="{FF2B5EF4-FFF2-40B4-BE49-F238E27FC236}">
-                <a16:creationId xmlns:a16="http://schemas.microsoft.com/office/drawing/2014/main" id="{200F2243-7318-4733-A3B5-7C0EFD67E4CD}"/>
+                <a16:creationId xmlns:a16="http://schemas.microsoft.com/office/drawing/2014/main" id="{89C3F34D-948E-4FB7-95DB-064316EF31FD}"/>
               </a:ext>
             </a:extLst>
           </p:cNvPr>
@@ -3576,7 +3576,7 @@
           <p:cNvPr id="3" name="">
             <a:extLst xmlns:a="http://schemas.openxmlformats.org/drawingml/2006/main">
               <a:ext uri="{FF2B5EF4-FFF2-40B4-BE49-F238E27FC236}">
-                <a16:creationId xmlns:a16="http://schemas.microsoft.com/office/drawing/2014/main" id="{E6E68664-6A98-48D5-BD66-17E461A10C2F}"/>
+                <a16:creationId xmlns:a16="http://schemas.microsoft.com/office/drawing/2014/main" id="{07946FE1-EE8B-45D0-9832-9CA09EF2D4DB}"/>
               </a:ext>
             </a:extLst>
           </p:cNvPr>
@@ -3606,7 +3606,7 @@
           <p:cNvPr id="4" name="">
             <a:extLst xmlns:a="http://schemas.openxmlformats.org/drawingml/2006/main">
               <a:ext uri="{FF2B5EF4-FFF2-40B4-BE49-F238E27FC236}">
-                <a16:creationId xmlns:a16="http://schemas.microsoft.com/office/drawing/2014/main" id="{26EE0404-868B-4AAB-9036-FE371743A67A}"/>
+                <a16:creationId xmlns:a16="http://schemas.microsoft.com/office/drawing/2014/main" id="{6F112857-368F-4978-8EC6-5C5E7092D64F}"/>
               </a:ext>
             </a:extLst>
           </p:cNvPr>
@@ -3661,7 +3661,7 @@
           <p:cNvPr id="5" name="">
             <a:extLst xmlns:a="http://schemas.openxmlformats.org/drawingml/2006/main">
               <a:ext uri="{FF2B5EF4-FFF2-40B4-BE49-F238E27FC236}">
-                <a16:creationId xmlns:a16="http://schemas.microsoft.com/office/drawing/2014/main" id="{1DDE5282-DE4D-47B9-ADA4-30A93898F3F2}"/>
+                <a16:creationId xmlns:a16="http://schemas.microsoft.com/office/drawing/2014/main" id="{1E913E5D-D6D4-4303-A25B-1CBE38C43A5F}"/>
               </a:ext>
             </a:extLst>
           </p:cNvPr>
@@ -3716,7 +3716,7 @@
           <p:cNvPr id="6" name="">
             <a:extLst xmlns:a="http://schemas.openxmlformats.org/drawingml/2006/main">
               <a:ext uri="{FF2B5EF4-FFF2-40B4-BE49-F238E27FC236}">
-                <a16:creationId xmlns:a16="http://schemas.microsoft.com/office/drawing/2014/main" id="{1585C610-B8E6-4D45-8346-9D51F902B8DE}"/>
+                <a16:creationId xmlns:a16="http://schemas.microsoft.com/office/drawing/2014/main" id="{E3E07EA1-040D-40B2-AF8B-CF4EE442F729}"/>
               </a:ext>
             </a:extLst>
           </p:cNvPr>
@@ -3771,7 +3771,7 @@
           <p:cNvPr id="7" name="">
             <a:extLst xmlns:a="http://schemas.openxmlformats.org/drawingml/2006/main">
               <a:ext uri="{FF2B5EF4-FFF2-40B4-BE49-F238E27FC236}">
-                <a16:creationId xmlns:a16="http://schemas.microsoft.com/office/drawing/2014/main" id="{5E444DBA-1947-4965-889B-955A23CFF21F}"/>
+                <a16:creationId xmlns:a16="http://schemas.microsoft.com/office/drawing/2014/main" id="{4E1D3996-8B4F-4F5F-9D68-816FD77DB8E2}"/>
               </a:ext>
             </a:extLst>
           </p:cNvPr>
@@ -3826,7 +3826,7 @@
           <p:cNvPr id="8" name="">
             <a:extLst xmlns:a="http://schemas.openxmlformats.org/drawingml/2006/main">
               <a:ext uri="{FF2B5EF4-FFF2-40B4-BE49-F238E27FC236}">
-                <a16:creationId xmlns:a16="http://schemas.microsoft.com/office/drawing/2014/main" id="{F97B166A-C2FE-4545-94BA-876DFFC332A4}"/>
+                <a16:creationId xmlns:a16="http://schemas.microsoft.com/office/drawing/2014/main" id="{EC6EFD07-A892-44A2-9447-F08BF3D9C42E}"/>
               </a:ext>
             </a:extLst>
           </p:cNvPr>
@@ -3881,7 +3881,7 @@
           <p:cNvPr id="9" name="">
             <a:extLst xmlns:a="http://schemas.openxmlformats.org/drawingml/2006/main">
               <a:ext uri="{FF2B5EF4-FFF2-40B4-BE49-F238E27FC236}">
-                <a16:creationId xmlns:a16="http://schemas.microsoft.com/office/drawing/2014/main" id="{1E08F6D9-C2F7-46B0-844F-A23CD6788228}"/>
+                <a16:creationId xmlns:a16="http://schemas.microsoft.com/office/drawing/2014/main" id="{0299B3D2-FD53-48CF-8264-B6A133D48E48}"/>
               </a:ext>
             </a:extLst>
           </p:cNvPr>
@@ -3936,7 +3936,7 @@
           <p:cNvPr id="10" name="">
             <a:extLst xmlns:a="http://schemas.openxmlformats.org/drawingml/2006/main">
               <a:ext uri="{FF2B5EF4-FFF2-40B4-BE49-F238E27FC236}">
-                <a16:creationId xmlns:a16="http://schemas.microsoft.com/office/drawing/2014/main" id="{648A2CBD-11B4-466B-99D1-F1BF6AFE2224}"/>
+                <a16:creationId xmlns:a16="http://schemas.microsoft.com/office/drawing/2014/main" id="{DCB51950-2624-4664-B25A-7724911EC05B}"/>
               </a:ext>
             </a:extLst>
           </p:cNvPr>
@@ -3989,7 +3989,7 @@
     </p:spTree>
     <p:extLst>
       <p:ext uri="{BB962C8B-B14F-4D97-AF65-F5344CB8AC3E}">
-        <p14:creationId xmlns:p14="http://schemas.microsoft.com/office/powerpoint/2010/main" val="1212257382"/>
+        <p14:creationId xmlns:p14="http://schemas.microsoft.com/office/powerpoint/2010/main" val="2096921802"/>
       </p:ext>
     </p:extLst>
   </p:cSld>
@@ -4020,7 +4020,7 @@
           <p:cNvPr id="7" name="">
             <a:extLst xmlns:a="http://schemas.openxmlformats.org/drawingml/2006/main">
               <a:ext uri="{FF2B5EF4-FFF2-40B4-BE49-F238E27FC236}">
-                <a16:creationId xmlns:a16="http://schemas.microsoft.com/office/drawing/2014/main" id="{46DCE110-59D6-436C-A0F7-68D07C1B63B0}"/>
+                <a16:creationId xmlns:a16="http://schemas.microsoft.com/office/drawing/2014/main" id="{2A96E7D1-6BD8-401A-B57C-198D3D9FB816}"/>
               </a:ext>
             </a:extLst>
           </p:cNvPr>
@@ -4075,7 +4075,7 @@
           <p:cNvPr id="2" name="">
             <a:extLst xmlns:a="http://schemas.openxmlformats.org/drawingml/2006/main">
               <a:ext uri="{FF2B5EF4-FFF2-40B4-BE49-F238E27FC236}">
-                <a16:creationId xmlns:a16="http://schemas.microsoft.com/office/drawing/2014/main" id="{AEC1510C-D070-4E95-BC39-64495D891AEB}"/>
+                <a16:creationId xmlns:a16="http://schemas.microsoft.com/office/drawing/2014/main" id="{BA0D084C-87EE-4637-83A8-6F0D07D34271}"/>
               </a:ext>
             </a:extLst>
           </p:cNvPr>
@@ -4130,7 +4130,7 @@
           <p:cNvPr id="3" name="">
             <a:extLst xmlns:a="http://schemas.openxmlformats.org/drawingml/2006/main">
               <a:ext uri="{FF2B5EF4-FFF2-40B4-BE49-F238E27FC236}">
-                <a16:creationId xmlns:a16="http://schemas.microsoft.com/office/drawing/2014/main" id="{546B4E79-055F-4E3C-8810-FC53CD472388}"/>
+                <a16:creationId xmlns:a16="http://schemas.microsoft.com/office/drawing/2014/main" id="{F208492A-1BFD-42EF-94C1-595F7A50C920}"/>
               </a:ext>
             </a:extLst>
           </p:cNvPr>
@@ -4164,7 +4164,7 @@
           <p:nvPr/>
         </p:nvPicPr>
         <p:blipFill>
-          <a:blip xmlns:r="http://schemas.openxmlformats.org/officeDocument/2006/relationships" xmlns:a="http://schemas.openxmlformats.org/drawingml/2006/main" r:embed="R941da8ecce6945c5"/>
+          <a:blip xmlns:r="http://schemas.openxmlformats.org/officeDocument/2006/relationships" xmlns:a="http://schemas.openxmlformats.org/drawingml/2006/main" r:embed="Rfa4273373cd146bc"/>
           <a:stretch xmlns:a="http://schemas.openxmlformats.org/drawingml/2006/main"/>
         </p:blipFill>
         <p:spPr>
@@ -4186,7 +4186,7 @@
           <p:nvPr/>
         </p:nvPicPr>
         <p:blipFill>
-          <a:blip xmlns:r="http://schemas.openxmlformats.org/officeDocument/2006/relationships" xmlns:a="http://schemas.openxmlformats.org/drawingml/2006/main" r:embed="R597539e31ac94d38"/>
+          <a:blip xmlns:r="http://schemas.openxmlformats.org/officeDocument/2006/relationships" xmlns:a="http://schemas.openxmlformats.org/drawingml/2006/main" r:embed="Rd36435beac814f22"/>
           <a:stretch xmlns:a="http://schemas.openxmlformats.org/drawingml/2006/main"/>
         </p:blipFill>
         <p:spPr>
@@ -4204,7 +4204,7 @@
           <p:cNvPr id="6" name="">
             <a:extLst xmlns:a="http://schemas.openxmlformats.org/drawingml/2006/main">
               <a:ext uri="{FF2B5EF4-FFF2-40B4-BE49-F238E27FC236}">
-                <a16:creationId xmlns:a16="http://schemas.microsoft.com/office/drawing/2014/main" id="{E06B9EAC-453F-4303-8680-BBD9D53D3192}"/>
+                <a16:creationId xmlns:a16="http://schemas.microsoft.com/office/drawing/2014/main" id="{1F19692C-F482-408A-B008-66DEB814F70E}"/>
               </a:ext>
             </a:extLst>
           </p:cNvPr>
@@ -4257,7 +4257,7 @@
     </p:spTree>
     <p:extLst>
       <p:ext uri="{BB962C8B-B14F-4D97-AF65-F5344CB8AC3E}">
-        <p14:creationId xmlns:p14="http://schemas.microsoft.com/office/powerpoint/2010/main" val="671139176"/>
+        <p14:creationId xmlns:p14="http://schemas.microsoft.com/office/powerpoint/2010/main" val="1753440381"/>
       </p:ext>
     </p:extLst>
   </p:cSld>
@@ -4288,7 +4288,7 @@
           <p:cNvPr id="13" name="">
             <a:extLst xmlns:a="http://schemas.openxmlformats.org/drawingml/2006/main">
               <a:ext uri="{FF2B5EF4-FFF2-40B4-BE49-F238E27FC236}">
-                <a16:creationId xmlns:a16="http://schemas.microsoft.com/office/drawing/2014/main" id="{83E40D9A-1866-48E8-B078-34465E6480A6}"/>
+                <a16:creationId xmlns:a16="http://schemas.microsoft.com/office/drawing/2014/main" id="{49A17808-BEA2-4918-8238-7F3E51F3CFC7}"/>
               </a:ext>
             </a:extLst>
           </p:cNvPr>
@@ -4343,7 +4343,7 @@
           <p:cNvPr id="2" name="">
             <a:extLst xmlns:a="http://schemas.openxmlformats.org/drawingml/2006/main">
               <a:ext uri="{FF2B5EF4-FFF2-40B4-BE49-F238E27FC236}">
-                <a16:creationId xmlns:a16="http://schemas.microsoft.com/office/drawing/2014/main" id="{2C4247F9-61C5-4F7F-9BFE-217C2C68B23E}"/>
+                <a16:creationId xmlns:a16="http://schemas.microsoft.com/office/drawing/2014/main" id="{7DFBB919-61B4-44FD-A17A-5774A357887A}"/>
               </a:ext>
             </a:extLst>
           </p:cNvPr>
@@ -4398,7 +4398,7 @@
           <p:cNvPr id="3" name="">
             <a:extLst xmlns:a="http://schemas.openxmlformats.org/drawingml/2006/main">
               <a:ext uri="{FF2B5EF4-FFF2-40B4-BE49-F238E27FC236}">
-                <a16:creationId xmlns:a16="http://schemas.microsoft.com/office/drawing/2014/main" id="{EFBC9AF0-BBB0-456F-B4CC-10F1D57FBA9B}"/>
+                <a16:creationId xmlns:a16="http://schemas.microsoft.com/office/drawing/2014/main" id="{9717BC0C-7983-46FD-A8AD-6B29A141259D}"/>
               </a:ext>
             </a:extLst>
           </p:cNvPr>
@@ -4428,7 +4428,7 @@
           <p:cNvPr id="4" name="">
             <a:extLst xmlns:a="http://schemas.openxmlformats.org/drawingml/2006/main">
               <a:ext uri="{FF2B5EF4-FFF2-40B4-BE49-F238E27FC236}">
-                <a16:creationId xmlns:a16="http://schemas.microsoft.com/office/drawing/2014/main" id="{2F7C6DEE-4E63-428B-BCBA-97867204A2B5}"/>
+                <a16:creationId xmlns:a16="http://schemas.microsoft.com/office/drawing/2014/main" id="{0D620E89-174E-4362-9E6D-F4569885C39E}"/>
               </a:ext>
             </a:extLst>
           </p:cNvPr>
@@ -4483,7 +4483,7 @@
           <p:cNvPr id="5" name="">
             <a:extLst xmlns:a="http://schemas.openxmlformats.org/drawingml/2006/main">
               <a:ext uri="{FF2B5EF4-FFF2-40B4-BE49-F238E27FC236}">
-                <a16:creationId xmlns:a16="http://schemas.microsoft.com/office/drawing/2014/main" id="{22BBEED3-F7E1-4F92-B9B6-FC3C654A62BF}"/>
+                <a16:creationId xmlns:a16="http://schemas.microsoft.com/office/drawing/2014/main" id="{A253B0DD-C5DB-4BC7-ADF9-33FA255A4109}"/>
               </a:ext>
             </a:extLst>
           </p:cNvPr>
@@ -4538,7 +4538,7 @@
           <p:cNvPr id="6" name="">
             <a:extLst xmlns:a="http://schemas.openxmlformats.org/drawingml/2006/main">
               <a:ext uri="{FF2B5EF4-FFF2-40B4-BE49-F238E27FC236}">
-                <a16:creationId xmlns:a16="http://schemas.microsoft.com/office/drawing/2014/main" id="{C630AD27-2559-4D5E-BEA3-DB85EA9C3A0C}"/>
+                <a16:creationId xmlns:a16="http://schemas.microsoft.com/office/drawing/2014/main" id="{9B052A41-D338-4199-8C9C-062AF87ECDE8}"/>
               </a:ext>
             </a:extLst>
           </p:cNvPr>
@@ -4593,7 +4593,7 @@
           <p:cNvPr id="7" name="">
             <a:extLst xmlns:a="http://schemas.openxmlformats.org/drawingml/2006/main">
               <a:ext uri="{FF2B5EF4-FFF2-40B4-BE49-F238E27FC236}">
-                <a16:creationId xmlns:a16="http://schemas.microsoft.com/office/drawing/2014/main" id="{F056152A-75F6-4A99-BDF8-F9B7FB260021}"/>
+                <a16:creationId xmlns:a16="http://schemas.microsoft.com/office/drawing/2014/main" id="{C8FCA256-4975-411A-970A-CEEE46871A26}"/>
               </a:ext>
             </a:extLst>
           </p:cNvPr>
@@ -4648,7 +4648,7 @@
           <p:cNvPr id="8" name="">
             <a:extLst xmlns:a="http://schemas.openxmlformats.org/drawingml/2006/main">
               <a:ext uri="{FF2B5EF4-FFF2-40B4-BE49-F238E27FC236}">
-                <a16:creationId xmlns:a16="http://schemas.microsoft.com/office/drawing/2014/main" id="{431FA615-17EF-43D4-8A93-9310FF415CAA}"/>
+                <a16:creationId xmlns:a16="http://schemas.microsoft.com/office/drawing/2014/main" id="{39D757B3-3DBA-48B4-9123-CC90DDD416DD}"/>
               </a:ext>
             </a:extLst>
           </p:cNvPr>
@@ -4703,7 +4703,7 @@
           <p:cNvPr id="9" name="">
             <a:extLst xmlns:a="http://schemas.openxmlformats.org/drawingml/2006/main">
               <a:ext uri="{FF2B5EF4-FFF2-40B4-BE49-F238E27FC236}">
-                <a16:creationId xmlns:a16="http://schemas.microsoft.com/office/drawing/2014/main" id="{9CF97142-9AA9-4EBA-B86B-33F4C7B02133}"/>
+                <a16:creationId xmlns:a16="http://schemas.microsoft.com/office/drawing/2014/main" id="{2D71962D-C14F-4E44-B7C6-54B851B9BD07}"/>
               </a:ext>
             </a:extLst>
           </p:cNvPr>
@@ -4758,7 +4758,7 @@
           <p:cNvPr id="10" name="">
             <a:extLst xmlns:a="http://schemas.openxmlformats.org/drawingml/2006/main">
               <a:ext uri="{FF2B5EF4-FFF2-40B4-BE49-F238E27FC236}">
-                <a16:creationId xmlns:a16="http://schemas.microsoft.com/office/drawing/2014/main" id="{F4CB2487-302C-40F0-BD2F-5CA2A565C6EE}"/>
+                <a16:creationId xmlns:a16="http://schemas.microsoft.com/office/drawing/2014/main" id="{0B83A68B-6A67-4343-A33F-C322F889C4CA}"/>
               </a:ext>
             </a:extLst>
           </p:cNvPr>
@@ -4813,7 +4813,7 @@
           <p:cNvPr id="11" name="">
             <a:extLst xmlns:a="http://schemas.openxmlformats.org/drawingml/2006/main">
               <a:ext uri="{FF2B5EF4-FFF2-40B4-BE49-F238E27FC236}">
-                <a16:creationId xmlns:a16="http://schemas.microsoft.com/office/drawing/2014/main" id="{945E20AD-43C9-4823-9888-AA9159CC407D}"/>
+                <a16:creationId xmlns:a16="http://schemas.microsoft.com/office/drawing/2014/main" id="{F874B902-AD8C-4287-92A5-AC8843414244}"/>
               </a:ext>
             </a:extLst>
           </p:cNvPr>
@@ -4868,7 +4868,7 @@
           <p:cNvPr id="12" name="">
             <a:extLst xmlns:a="http://schemas.openxmlformats.org/drawingml/2006/main">
               <a:ext uri="{FF2B5EF4-FFF2-40B4-BE49-F238E27FC236}">
-                <a16:creationId xmlns:a16="http://schemas.microsoft.com/office/drawing/2014/main" id="{78985F6F-37F2-440F-BD12-BC91375F7572}"/>
+                <a16:creationId xmlns:a16="http://schemas.microsoft.com/office/drawing/2014/main" id="{303EDA89-0F4C-4163-BEBF-28DA76D3F21F}"/>
               </a:ext>
             </a:extLst>
           </p:cNvPr>
@@ -4921,7 +4921,7 @@
     </p:spTree>
     <p:extLst>
       <p:ext uri="{BB962C8B-B14F-4D97-AF65-F5344CB8AC3E}">
-        <p14:creationId xmlns:p14="http://schemas.microsoft.com/office/powerpoint/2010/main" val="352274665"/>
+        <p14:creationId xmlns:p14="http://schemas.microsoft.com/office/powerpoint/2010/main" val="2074042078"/>
       </p:ext>
     </p:extLst>
   </p:cSld>
@@ -4952,7 +4952,7 @@
           <p:cNvPr id="9" name="">
             <a:extLst xmlns:a="http://schemas.openxmlformats.org/drawingml/2006/main">
               <a:ext uri="{FF2B5EF4-FFF2-40B4-BE49-F238E27FC236}">
-                <a16:creationId xmlns:a16="http://schemas.microsoft.com/office/drawing/2014/main" id="{8FFB5699-DEC1-41E8-8784-C60AD0B0794F}"/>
+                <a16:creationId xmlns:a16="http://schemas.microsoft.com/office/drawing/2014/main" id="{11E22146-D469-41F9-99C6-3A0AB651DFEF}"/>
               </a:ext>
             </a:extLst>
           </p:cNvPr>
@@ -5007,7 +5007,7 @@
           <p:cNvPr id="2" name="">
             <a:extLst xmlns:a="http://schemas.openxmlformats.org/drawingml/2006/main">
               <a:ext uri="{FF2B5EF4-FFF2-40B4-BE49-F238E27FC236}">
-                <a16:creationId xmlns:a16="http://schemas.microsoft.com/office/drawing/2014/main" id="{F27A996F-74C4-48C5-9754-BC4DCDB66B53}"/>
+                <a16:creationId xmlns:a16="http://schemas.microsoft.com/office/drawing/2014/main" id="{5E9C9BBA-168F-495F-A9BD-6552792681B9}"/>
               </a:ext>
             </a:extLst>
           </p:cNvPr>
@@ -5062,7 +5062,7 @@
           <p:cNvPr id="3" name="">
             <a:extLst xmlns:a="http://schemas.openxmlformats.org/drawingml/2006/main">
               <a:ext uri="{FF2B5EF4-FFF2-40B4-BE49-F238E27FC236}">
-                <a16:creationId xmlns:a16="http://schemas.microsoft.com/office/drawing/2014/main" id="{53149D3D-FCBD-4236-8B73-7D9529FF1DAE}"/>
+                <a16:creationId xmlns:a16="http://schemas.microsoft.com/office/drawing/2014/main" id="{58496D86-1E82-42AB-869C-6F7775E11FB7}"/>
               </a:ext>
             </a:extLst>
           </p:cNvPr>
@@ -5092,7 +5092,7 @@
           <p:cNvPr id="4" name="">
             <a:extLst xmlns:a="http://schemas.openxmlformats.org/drawingml/2006/main">
               <a:ext uri="{FF2B5EF4-FFF2-40B4-BE49-F238E27FC236}">
-                <a16:creationId xmlns:a16="http://schemas.microsoft.com/office/drawing/2014/main" id="{5FF2E565-9148-48E7-AD12-8D94375DFD31}"/>
+                <a16:creationId xmlns:a16="http://schemas.microsoft.com/office/drawing/2014/main" id="{94ADF79A-6B61-4DA8-AC9A-5D0315919ED7}"/>
               </a:ext>
             </a:extLst>
           </p:cNvPr>
@@ -5147,7 +5147,7 @@
           <p:cNvPr id="5" name="">
             <a:extLst xmlns:a="http://schemas.openxmlformats.org/drawingml/2006/main">
               <a:ext uri="{FF2B5EF4-FFF2-40B4-BE49-F238E27FC236}">
-                <a16:creationId xmlns:a16="http://schemas.microsoft.com/office/drawing/2014/main" id="{3EFD8B96-0D5B-45BB-B214-C9C547307431}"/>
+                <a16:creationId xmlns:a16="http://schemas.microsoft.com/office/drawing/2014/main" id="{F7745BE3-F812-440F-A9E5-C0EE09610C41}"/>
               </a:ext>
             </a:extLst>
           </p:cNvPr>
@@ -5202,7 +5202,7 @@
           <p:cNvPr id="6" name="">
             <a:extLst xmlns:a="http://schemas.openxmlformats.org/drawingml/2006/main">
               <a:ext uri="{FF2B5EF4-FFF2-40B4-BE49-F238E27FC236}">
-                <a16:creationId xmlns:a16="http://schemas.microsoft.com/office/drawing/2014/main" id="{37946BE6-51C4-4C0A-A130-7C2C92F00CD7}"/>
+                <a16:creationId xmlns:a16="http://schemas.microsoft.com/office/drawing/2014/main" id="{94FFE971-029D-442A-92B9-717D6FD6DE07}"/>
               </a:ext>
             </a:extLst>
           </p:cNvPr>
@@ -5257,7 +5257,7 @@
           <p:cNvPr id="7" name="">
             <a:extLst xmlns:a="http://schemas.openxmlformats.org/drawingml/2006/main">
               <a:ext uri="{FF2B5EF4-FFF2-40B4-BE49-F238E27FC236}">
-                <a16:creationId xmlns:a16="http://schemas.microsoft.com/office/drawing/2014/main" id="{A476A3AD-3AB1-4FCC-A2EC-EFC653CAC2A1}"/>
+                <a16:creationId xmlns:a16="http://schemas.microsoft.com/office/drawing/2014/main" id="{E1EF1B4D-0917-4E59-A03E-89AF4F576846}"/>
               </a:ext>
             </a:extLst>
           </p:cNvPr>
@@ -5312,7 +5312,7 @@
           <p:cNvPr id="8" name="">
             <a:extLst xmlns:a="http://schemas.openxmlformats.org/drawingml/2006/main">
               <a:ext uri="{FF2B5EF4-FFF2-40B4-BE49-F238E27FC236}">
-                <a16:creationId xmlns:a16="http://schemas.microsoft.com/office/drawing/2014/main" id="{8E425905-ECA7-458B-92B4-48E16ED44555}"/>
+                <a16:creationId xmlns:a16="http://schemas.microsoft.com/office/drawing/2014/main" id="{22F9F735-061D-4C49-80A8-503AC17B128E}"/>
               </a:ext>
             </a:extLst>
           </p:cNvPr>
@@ -5365,7 +5365,7 @@
     </p:spTree>
     <p:extLst>
       <p:ext uri="{BB962C8B-B14F-4D97-AF65-F5344CB8AC3E}">
-        <p14:creationId xmlns:p14="http://schemas.microsoft.com/office/powerpoint/2010/main" val="924182807"/>
+        <p14:creationId xmlns:p14="http://schemas.microsoft.com/office/powerpoint/2010/main" val="174829106"/>
       </p:ext>
     </p:extLst>
   </p:cSld>
@@ -5396,7 +5396,7 @@
           <p:cNvPr id="10" name="">
             <a:extLst xmlns:a="http://schemas.openxmlformats.org/drawingml/2006/main">
               <a:ext uri="{FF2B5EF4-FFF2-40B4-BE49-F238E27FC236}">
-                <a16:creationId xmlns:a16="http://schemas.microsoft.com/office/drawing/2014/main" id="{F0DA8678-E080-4A2B-B26A-F810DBC9B865}"/>
+                <a16:creationId xmlns:a16="http://schemas.microsoft.com/office/drawing/2014/main" id="{C733598D-1DEE-4B13-9C2D-1033FCF9090B}"/>
               </a:ext>
             </a:extLst>
           </p:cNvPr>
@@ -5451,7 +5451,7 @@
           <p:cNvPr id="2" name="">
             <a:extLst xmlns:a="http://schemas.openxmlformats.org/drawingml/2006/main">
               <a:ext uri="{FF2B5EF4-FFF2-40B4-BE49-F238E27FC236}">
-                <a16:creationId xmlns:a16="http://schemas.microsoft.com/office/drawing/2014/main" id="{5756ECE5-2775-415F-99E1-E105DE922725}"/>
+                <a16:creationId xmlns:a16="http://schemas.microsoft.com/office/drawing/2014/main" id="{700C2046-C854-4B30-955A-6DC7D808D93F}"/>
               </a:ext>
             </a:extLst>
           </p:cNvPr>
@@ -5506,7 +5506,7 @@
           <p:cNvPr id="3" name="">
             <a:extLst xmlns:a="http://schemas.openxmlformats.org/drawingml/2006/main">
               <a:ext uri="{FF2B5EF4-FFF2-40B4-BE49-F238E27FC236}">
-                <a16:creationId xmlns:a16="http://schemas.microsoft.com/office/drawing/2014/main" id="{8345BDF6-CD4D-45A0-B4E7-CD6F672626E5}"/>
+                <a16:creationId xmlns:a16="http://schemas.microsoft.com/office/drawing/2014/main" id="{C1DAA7C1-95CC-47D1-8F2F-9A95ED9F7272}"/>
               </a:ext>
             </a:extLst>
           </p:cNvPr>
@@ -5536,7 +5536,7 @@
           <p:cNvPr id="4" name="">
             <a:extLst xmlns:a="http://schemas.openxmlformats.org/drawingml/2006/main">
               <a:ext uri="{FF2B5EF4-FFF2-40B4-BE49-F238E27FC236}">
-                <a16:creationId xmlns:a16="http://schemas.microsoft.com/office/drawing/2014/main" id="{2C64E9F7-F234-46FA-A3B9-34693923D665}"/>
+                <a16:creationId xmlns:a16="http://schemas.microsoft.com/office/drawing/2014/main" id="{FDB5F2AE-A4E3-47D0-BA83-56E49AD9CCDD}"/>
               </a:ext>
             </a:extLst>
           </p:cNvPr>
@@ -5591,7 +5591,7 @@
           <p:cNvPr id="5" name="">
             <a:extLst xmlns:a="http://schemas.openxmlformats.org/drawingml/2006/main">
               <a:ext uri="{FF2B5EF4-FFF2-40B4-BE49-F238E27FC236}">
-                <a16:creationId xmlns:a16="http://schemas.microsoft.com/office/drawing/2014/main" id="{BFFA6AAF-8F5A-4D7B-9F76-C19E17A7E184}"/>
+                <a16:creationId xmlns:a16="http://schemas.microsoft.com/office/drawing/2014/main" id="{B720F82F-253C-4764-8F4D-9A3EB2F1EF0A}"/>
               </a:ext>
             </a:extLst>
           </p:cNvPr>
@@ -5646,7 +5646,7 @@
           <p:cNvPr id="6" name="">
             <a:extLst xmlns:a="http://schemas.openxmlformats.org/drawingml/2006/main">
               <a:ext uri="{FF2B5EF4-FFF2-40B4-BE49-F238E27FC236}">
-                <a16:creationId xmlns:a16="http://schemas.microsoft.com/office/drawing/2014/main" id="{90B86A57-6FB2-4AD9-9E45-0AE64EA5BF0A}"/>
+                <a16:creationId xmlns:a16="http://schemas.microsoft.com/office/drawing/2014/main" id="{6266FBEF-903B-4063-AF62-36241E0356DF}"/>
               </a:ext>
             </a:extLst>
           </p:cNvPr>
@@ -5701,7 +5701,7 @@
           <p:cNvPr id="7" name="">
             <a:extLst xmlns:a="http://schemas.openxmlformats.org/drawingml/2006/main">
               <a:ext uri="{FF2B5EF4-FFF2-40B4-BE49-F238E27FC236}">
-                <a16:creationId xmlns:a16="http://schemas.microsoft.com/office/drawing/2014/main" id="{8AEA67C2-0BDF-40C2-91BF-6F479A9E755A}"/>
+                <a16:creationId xmlns:a16="http://schemas.microsoft.com/office/drawing/2014/main" id="{69E1C351-FE34-4B94-8D52-450231D735E4}"/>
               </a:ext>
             </a:extLst>
           </p:cNvPr>
@@ -5756,7 +5756,7 @@
           <p:cNvPr id="8" name="">
             <a:extLst xmlns:a="http://schemas.openxmlformats.org/drawingml/2006/main">
               <a:ext uri="{FF2B5EF4-FFF2-40B4-BE49-F238E27FC236}">
-                <a16:creationId xmlns:a16="http://schemas.microsoft.com/office/drawing/2014/main" id="{4D8DAA31-A447-484F-A462-81B56693A6F9}"/>
+                <a16:creationId xmlns:a16="http://schemas.microsoft.com/office/drawing/2014/main" id="{2D43E05F-ACDA-4DBA-91FE-2C1B4BFC84F6}"/>
               </a:ext>
             </a:extLst>
           </p:cNvPr>
@@ -5811,7 +5811,7 @@
           <p:cNvPr id="9" name="">
             <a:extLst xmlns:a="http://schemas.openxmlformats.org/drawingml/2006/main">
               <a:ext uri="{FF2B5EF4-FFF2-40B4-BE49-F238E27FC236}">
-                <a16:creationId xmlns:a16="http://schemas.microsoft.com/office/drawing/2014/main" id="{F0A45E7D-9472-48BC-B22E-EB9F1C04C50E}"/>
+                <a16:creationId xmlns:a16="http://schemas.microsoft.com/office/drawing/2014/main" id="{0A520D93-A6E8-4A9C-BE85-C3335EBE7FEF}"/>
               </a:ext>
             </a:extLst>
           </p:cNvPr>
@@ -5910,7 +5910,7 @@
     </p:spTree>
     <p:extLst>
       <p:ext uri="{BB962C8B-B14F-4D97-AF65-F5344CB8AC3E}">
-        <p14:creationId xmlns:p14="http://schemas.microsoft.com/office/powerpoint/2010/main" val="1732018056"/>
+        <p14:creationId xmlns:p14="http://schemas.microsoft.com/office/powerpoint/2010/main" val="72731115"/>
       </p:ext>
     </p:extLst>
   </p:cSld>
@@ -5941,7 +5941,7 @@
           <p:cNvPr id="9" name="">
             <a:extLst xmlns:a="http://schemas.openxmlformats.org/drawingml/2006/main">
               <a:ext uri="{FF2B5EF4-FFF2-40B4-BE49-F238E27FC236}">
-                <a16:creationId xmlns:a16="http://schemas.microsoft.com/office/drawing/2014/main" id="{7D8EE3CC-EAC9-4610-9034-81F76A0F88D7}"/>
+                <a16:creationId xmlns:a16="http://schemas.microsoft.com/office/drawing/2014/main" id="{8E00B589-3D95-4B11-917D-28F759B9227A}"/>
               </a:ext>
             </a:extLst>
           </p:cNvPr>
@@ -5996,7 +5996,7 @@
           <p:cNvPr id="2" name="">
             <a:extLst xmlns:a="http://schemas.openxmlformats.org/drawingml/2006/main">
               <a:ext uri="{FF2B5EF4-FFF2-40B4-BE49-F238E27FC236}">
-                <a16:creationId xmlns:a16="http://schemas.microsoft.com/office/drawing/2014/main" id="{E75AF225-45BC-42A4-A272-510147E04F3D}"/>
+                <a16:creationId xmlns:a16="http://schemas.microsoft.com/office/drawing/2014/main" id="{325B8784-D588-438E-B6C8-E72C53E1B883}"/>
               </a:ext>
             </a:extLst>
           </p:cNvPr>
@@ -6051,7 +6051,7 @@
           <p:cNvPr id="3" name="">
             <a:extLst xmlns:a="http://schemas.openxmlformats.org/drawingml/2006/main">
               <a:ext uri="{FF2B5EF4-FFF2-40B4-BE49-F238E27FC236}">
-                <a16:creationId xmlns:a16="http://schemas.microsoft.com/office/drawing/2014/main" id="{B41E3E3A-7456-4C0F-8784-BCEA63FF27EC}"/>
+                <a16:creationId xmlns:a16="http://schemas.microsoft.com/office/drawing/2014/main" id="{7A85C7AB-D7ED-4329-84BE-5D9918B056FC}"/>
               </a:ext>
             </a:extLst>
           </p:cNvPr>
@@ -6085,7 +6085,7 @@
           <p:nvPr/>
         </p:nvPicPr>
         <p:blipFill>
-          <a:blip xmlns:r="http://schemas.openxmlformats.org/officeDocument/2006/relationships" xmlns:a="http://schemas.openxmlformats.org/drawingml/2006/main" r:embed="R50a5b0e74a244619"/>
+          <a:blip xmlns:r="http://schemas.openxmlformats.org/officeDocument/2006/relationships" xmlns:a="http://schemas.openxmlformats.org/drawingml/2006/main" r:embed="R22b047b5b5e04833"/>
           <a:stretch xmlns:a="http://schemas.openxmlformats.org/drawingml/2006/main"/>
         </p:blipFill>
         <p:spPr>
@@ -6103,7 +6103,7 @@
           <p:cNvPr id="5" name="">
             <a:extLst xmlns:a="http://schemas.openxmlformats.org/drawingml/2006/main">
               <a:ext uri="{FF2B5EF4-FFF2-40B4-BE49-F238E27FC236}">
-                <a16:creationId xmlns:a16="http://schemas.microsoft.com/office/drawing/2014/main" id="{3944B31F-3ACD-4A18-9F54-51B5F1BC0D37}"/>
+                <a16:creationId xmlns:a16="http://schemas.microsoft.com/office/drawing/2014/main" id="{1AA99693-956D-42DF-9550-0E83784E5E5C}"/>
               </a:ext>
             </a:extLst>
           </p:cNvPr>
@@ -6158,7 +6158,7 @@
           <p:cNvPr id="6" name="">
             <a:extLst xmlns:a="http://schemas.openxmlformats.org/drawingml/2006/main">
               <a:ext uri="{FF2B5EF4-FFF2-40B4-BE49-F238E27FC236}">
-                <a16:creationId xmlns:a16="http://schemas.microsoft.com/office/drawing/2014/main" id="{7C014828-033A-4B75-A31A-D4AE3DD4DDE8}"/>
+                <a16:creationId xmlns:a16="http://schemas.microsoft.com/office/drawing/2014/main" id="{45D52CB0-7888-46DF-AB81-2FAC7A5C71A1}"/>
               </a:ext>
             </a:extLst>
           </p:cNvPr>
@@ -6236,7 +6236,7 @@
           <p:cNvPr id="7" name="">
             <a:extLst xmlns:a="http://schemas.openxmlformats.org/drawingml/2006/main">
               <a:ext uri="{FF2B5EF4-FFF2-40B4-BE49-F238E27FC236}">
-                <a16:creationId xmlns:a16="http://schemas.microsoft.com/office/drawing/2014/main" id="{9F361595-D460-4C05-AFB6-84D1711849CB}"/>
+                <a16:creationId xmlns:a16="http://schemas.microsoft.com/office/drawing/2014/main" id="{6208A956-24C3-42FD-B12C-A04C5EF38DEC}"/>
               </a:ext>
             </a:extLst>
           </p:cNvPr>
@@ -6291,7 +6291,7 @@
           <p:cNvPr id="8" name="">
             <a:extLst xmlns:a="http://schemas.openxmlformats.org/drawingml/2006/main">
               <a:ext uri="{FF2B5EF4-FFF2-40B4-BE49-F238E27FC236}">
-                <a16:creationId xmlns:a16="http://schemas.microsoft.com/office/drawing/2014/main" id="{512AD5D6-999E-46EC-A115-EE24A55A442D}"/>
+                <a16:creationId xmlns:a16="http://schemas.microsoft.com/office/drawing/2014/main" id="{FA273D61-0D6E-4C75-B53A-87F9EFBFB36E}"/>
               </a:ext>
             </a:extLst>
           </p:cNvPr>
@@ -6367,7 +6367,7 @@
     </p:spTree>
     <p:extLst>
       <p:ext uri="{BB962C8B-B14F-4D97-AF65-F5344CB8AC3E}">
-        <p14:creationId xmlns:p14="http://schemas.microsoft.com/office/powerpoint/2010/main" val="1039163611"/>
+        <p14:creationId xmlns:p14="http://schemas.microsoft.com/office/powerpoint/2010/main" val="2098729189"/>
       </p:ext>
     </p:extLst>
   </p:cSld>
@@ -6398,7 +6398,7 @@
           <p:cNvPr id="7" name="">
             <a:extLst xmlns:a="http://schemas.openxmlformats.org/drawingml/2006/main">
               <a:ext uri="{FF2B5EF4-FFF2-40B4-BE49-F238E27FC236}">
-                <a16:creationId xmlns:a16="http://schemas.microsoft.com/office/drawing/2014/main" id="{71A1C4A7-57AC-4E5B-BABC-12FDF9D533A2}"/>
+                <a16:creationId xmlns:a16="http://schemas.microsoft.com/office/drawing/2014/main" id="{C2F3C980-A2EA-4F0D-8032-F593098FA46B}"/>
               </a:ext>
             </a:extLst>
           </p:cNvPr>
@@ -6453,7 +6453,7 @@
           <p:cNvPr id="2" name="">
             <a:extLst xmlns:a="http://schemas.openxmlformats.org/drawingml/2006/main">
               <a:ext uri="{FF2B5EF4-FFF2-40B4-BE49-F238E27FC236}">
-                <a16:creationId xmlns:a16="http://schemas.microsoft.com/office/drawing/2014/main" id="{9B1E18AF-26FA-4E1A-82A3-4D40D2D162DA}"/>
+                <a16:creationId xmlns:a16="http://schemas.microsoft.com/office/drawing/2014/main" id="{04F834D8-9F50-4DCB-A028-D9016C03C772}"/>
               </a:ext>
             </a:extLst>
           </p:cNvPr>
@@ -6508,7 +6508,7 @@
           <p:cNvPr id="3" name="">
             <a:extLst xmlns:a="http://schemas.openxmlformats.org/drawingml/2006/main">
               <a:ext uri="{FF2B5EF4-FFF2-40B4-BE49-F238E27FC236}">
-                <a16:creationId xmlns:a16="http://schemas.microsoft.com/office/drawing/2014/main" id="{6FBDA74F-A5EF-4C08-B566-4AC4E28F5D1E}"/>
+                <a16:creationId xmlns:a16="http://schemas.microsoft.com/office/drawing/2014/main" id="{F9A7C52A-496B-44A2-9D25-7D3FDE1B114E}"/>
               </a:ext>
             </a:extLst>
           </p:cNvPr>
@@ -6542,13 +6542,13 @@
           <p:nvPr/>
         </p:nvPicPr>
         <p:blipFill>
-          <a:blip xmlns:r="http://schemas.openxmlformats.org/officeDocument/2006/relationships" xmlns:a="http://schemas.openxmlformats.org/drawingml/2006/main" r:embed="R3e15cf6bbb8744c1"/>
+          <a:blip xmlns:r="http://schemas.openxmlformats.org/officeDocument/2006/relationships" xmlns:a="http://schemas.openxmlformats.org/drawingml/2006/main" r:embed="R63564c2b015a4ef8"/>
           <a:stretch xmlns:a="http://schemas.openxmlformats.org/drawingml/2006/main"/>
         </p:blipFill>
         <p:spPr>
           <a:xfrm xmlns:a="http://schemas.openxmlformats.org/drawingml/2006/main">
-            <a:off x="714375" y="2111375"/>
-            <a:ext cx="4762500" cy="1587500"/>
+            <a:off x="714375" y="2054679"/>
+            <a:ext cx="4762500" cy="1700893"/>
           </a:xfrm>
           <a:prstGeom xmlns:a="http://schemas.openxmlformats.org/drawingml/2006/main" prst="rect">
             <a:avLst/>
@@ -6564,13 +6564,13 @@
           <p:nvPr/>
         </p:nvPicPr>
         <p:blipFill>
-          <a:blip xmlns:r="http://schemas.openxmlformats.org/officeDocument/2006/relationships" xmlns:a="http://schemas.openxmlformats.org/drawingml/2006/main" r:embed="R5e8ee2b7ed9e43ca"/>
+          <a:blip xmlns:r="http://schemas.openxmlformats.org/officeDocument/2006/relationships" xmlns:a="http://schemas.openxmlformats.org/drawingml/2006/main" r:embed="R3d8fe0ed3427419c"/>
           <a:stretch xmlns:a="http://schemas.openxmlformats.org/drawingml/2006/main"/>
         </p:blipFill>
         <p:spPr>
           <a:xfrm xmlns:a="http://schemas.openxmlformats.org/drawingml/2006/main">
-            <a:off x="6191250" y="2111375"/>
-            <a:ext cx="4762500" cy="1587500"/>
+            <a:off x="6191250" y="2054679"/>
+            <a:ext cx="4762500" cy="1700893"/>
           </a:xfrm>
           <a:prstGeom xmlns:a="http://schemas.openxmlformats.org/drawingml/2006/main" prst="rect">
             <a:avLst/>
@@ -6582,7 +6582,7 @@
           <p:cNvPr id="6" name="">
             <a:extLst xmlns:a="http://schemas.openxmlformats.org/drawingml/2006/main">
               <a:ext uri="{FF2B5EF4-FFF2-40B4-BE49-F238E27FC236}">
-                <a16:creationId xmlns:a16="http://schemas.microsoft.com/office/drawing/2014/main" id="{F7A25187-3585-4942-A5DD-899B0404B321}"/>
+                <a16:creationId xmlns:a16="http://schemas.microsoft.com/office/drawing/2014/main" id="{D8D25003-5FBD-43D7-9711-DBEB9A026CA0}"/>
               </a:ext>
             </a:extLst>
           </p:cNvPr>
@@ -6635,7 +6635,7 @@
     </p:spTree>
     <p:extLst>
       <p:ext uri="{BB962C8B-B14F-4D97-AF65-F5344CB8AC3E}">
-        <p14:creationId xmlns:p14="http://schemas.microsoft.com/office/powerpoint/2010/main" val="1175396664"/>
+        <p14:creationId xmlns:p14="http://schemas.microsoft.com/office/powerpoint/2010/main" val="1436048217"/>
       </p:ext>
     </p:extLst>
   </p:cSld>

</xml_diff>